<commit_message>
Fix encoding issue in PowerPoint: use ASCII-only strings
Accented characters (e, e, a, etc.) and Unicode symbols were
rendered as raw UTF-8 byte sequences (<c3><a9> etc.) in officer.
Replaced all non-ASCII characters with ASCII equivalents throughout
make_presentation.R and regenerated TDXD_presentation.pptx.

https://claude.ai/code/session_01Q6imMLyo5kgcVayH9v31Ju
</commit_message>
<xml_diff>
--- a/scripts_tdxd/TDXD_presentation.pptx
+++ b/scripts_tdxd/TDXD_presentation.pptx
@@ -2247,8 +2247,8 @@
           <a:p>
             <a:r>
               <a:rPr/>
-              <a:t>Mod&lt;c3&gt;&lt;a8&gt;le PK/PD T-DXd
-Toxicit&lt;c3&gt;&lt;a9&gt; h&lt;c3&gt;&lt;a9&gt;matologique</a:t>
+              <a:t>Modele PK/PD T-DXd
+Toxicite hematologique</a:t>
             </a:r>
           </a:p>
         </p:txBody>
@@ -2275,7 +2275,7 @@
           <a:p>
             <a:r>
               <a:rPr/>
-              <a:t>Rat (pr&lt;c3&gt;&lt;a9&gt;clinique) &lt;e2&gt;&lt;86&gt;&lt;92&gt; Humain (clinique)
+              <a:t>Rat (preclinique) -&gt; Humain (clinique)
 DESTINY-Breast01 | FDA BLA 761139</a:t>
             </a:r>
           </a:p>
@@ -2328,7 +2328,7 @@
           <a:p>
             <a:r>
               <a:rPr/>
-              <a:t>Limitation principale : accumulation de l'ADC</a:t>
+              <a:t>Limitation : accumulation de l'ADC entre cycles</a:t>
             </a:r>
           </a:p>
         </p:txBody>
@@ -2405,7 +2405,7 @@
                 <a:ea typeface="Arial"/>
                 <a:sym typeface="Arial"/>
               </a:rPr>
-              <a:t>  T&lt;c2&gt;&lt;bd&gt; terminale ADC &lt;e2&gt;&lt;89&gt;&lt;88&gt; 23 jours  &gt;  intervalle Q3W = 21 jours</a:t>
+              <a:t>  T1/2 terminale ADC ~ 23 jours  &gt;  intervalle Q3W = 21 jours</a:t>
             </a:r>
           </a:p>
           <a:p>
@@ -2433,7 +2433,7 @@
                 <a:ea typeface="Arial"/>
                 <a:sym typeface="Arial"/>
               </a:rPr>
-              <a:t>  &lt;e2&gt;&lt;86&gt;&lt;92&gt; Le m&lt;c3&gt;&lt;a9&gt;dicament s'accumule entre les cycles</a:t>
+              <a:t>  -&gt; Le medicament s'accumule entre les cycles</a:t>
             </a:r>
           </a:p>
           <a:p>
@@ -2461,7 +2461,7 @@
                 <a:ea typeface="Arial"/>
                 <a:sym typeface="Arial"/>
               </a:rPr>
-              <a:t>  &lt;e2&gt;&lt;86&gt;&lt;92&gt; Signal Damage jamais nul &lt;e2&gt;&lt;86&gt;&lt;92&gt; tous les patients ont une chute de Neut</a:t>
+              <a:t>  -&gt; Signal Damage jamais nul -&gt; tous les patients ont une chute de Neut</a:t>
             </a:r>
           </a:p>
           <a:p>
@@ -2506,7 +2506,7 @@
                 <a:ea typeface="Arial"/>
                 <a:sym typeface="Arial"/>
               </a:rPr>
-              <a:t>Cons&lt;c3&gt;&lt;a9&gt;quence :</a:t>
+              <a:t>Consequence :</a:t>
             </a:r>
           </a:p>
           <a:p>
@@ -2534,7 +2534,7 @@
                 <a:ea typeface="Arial"/>
                 <a:sym typeface="Arial"/>
               </a:rPr>
-              <a:t>  0% G0 dans le mod&lt;c3&gt;&lt;a8&gt;le vs 71% en clinique</a:t>
+              <a:t>  0% G0 dans le modele vs 71% en clinique</a:t>
             </a:r>
           </a:p>
           <a:p>
@@ -2579,7 +2579,7 @@
                 <a:ea typeface="Arial"/>
                 <a:sym typeface="Arial"/>
               </a:rPr>
-              <a:t>R&lt;c3&gt;&lt;a9&gt;f&lt;c3&gt;&lt;a9&gt;rence :</a:t>
+              <a:t>Reference :</a:t>
             </a:r>
           </a:p>
           <a:p>
@@ -2635,7 +2635,7 @@
                 <a:ea typeface="Arial"/>
                 <a:sym typeface="Arial"/>
               </a:rPr>
-              <a:t>  &lt;e2&gt;&lt;86&gt;&lt;92&gt; Mod&lt;c3&gt;&lt;a8&gt;le Fornari/Friberg non adapt&lt;c3&gt;&lt;a9&gt; aux ADC &lt;c3&gt;&lt;a0&gt; longue demi-vie</a:t>
+              <a:t>  -&gt; Modele Fornari/Friberg non adapte aux ADC a longue demi-vie</a:t>
             </a:r>
           </a:p>
           <a:p>
@@ -2663,7 +2663,7 @@
                 <a:ea typeface="Arial"/>
                 <a:sym typeface="Arial"/>
               </a:rPr>
-              <a:t>  Fornari 2019 : valid&lt;c3&gt;&lt;a9&gt; uniquement sur le carboplatine (T&lt;c2&gt;&lt;bd&gt; &lt;e2&gt;&lt;89&gt;&lt;88&gt; 2h)</a:t>
+              <a:t>  Fornari 2019 : valide uniquement sur le carboplatine (T1/2 ~ 2h)</a:t>
             </a:r>
           </a:p>
         </p:txBody>
@@ -2764,7 +2764,7 @@
                 <a:ea typeface="Arial"/>
                 <a:sym typeface="Arial"/>
               </a:rPr>
-              <a:t>Option 1 &lt;e2&gt;&lt;80&gt;&lt;94&gt; Corriger la distribution des grades</a:t>
+              <a:t>Option 1 -- Corriger la distribution des grades</a:t>
             </a:r>
           </a:p>
           <a:p>
@@ -2792,7 +2792,7 @@
                 <a:ea typeface="Arial"/>
                 <a:sym typeface="Arial"/>
               </a:rPr>
-              <a:t>  Augmenter IC50_ADC in vivo (les prog&lt;c3&gt;&lt;a9&gt;niteurs HPC expriment peu HER2)</a:t>
+              <a:t>  Augmenter IC50_ADC in vivo (les progeniteurs HPC expriment peu HER2)</a:t>
             </a:r>
           </a:p>
           <a:p>
@@ -2820,7 +2820,7 @@
                 <a:ea typeface="Arial"/>
                 <a:sym typeface="Arial"/>
               </a:rPr>
-              <a:t>  &lt;e2&gt;&lt;86&gt;&lt;92&gt; Recalibrer Slope_CMP sur les nouvelles donn&lt;c3&gt;&lt;a9&gt;es de Damage</a:t>
+              <a:t>  -&gt; Recalibrer Slope_CMP sur les nouvelles donnees de Damage</a:t>
             </a:r>
           </a:p>
           <a:p>
@@ -2865,7 +2865,7 @@
                 <a:ea typeface="Arial"/>
                 <a:sym typeface="Arial"/>
               </a:rPr>
-              <a:t>Option 2 &lt;e2&gt;&lt;80&gt;&lt;94&gt; Explorer d'autres doses</a:t>
+              <a:t>Option 2 -- Explorer d'autres doses</a:t>
             </a:r>
           </a:p>
           <a:p>
@@ -2893,7 +2893,7 @@
                 <a:ea typeface="Arial"/>
                 <a:sym typeface="Arial"/>
               </a:rPr>
-              <a:t>  Simuler 6.4 mg/kg Q3W (dose sup&lt;c3&gt;&lt;a9&gt;rieure explor&lt;c3&gt;&lt;a9&gt;e en essai)</a:t>
+              <a:t>  Simuler 6.4 mg/kg Q3W (dose superieure exploree en essai)</a:t>
             </a:r>
           </a:p>
           <a:p>
@@ -2921,7 +2921,7 @@
                 <a:ea typeface="Arial"/>
                 <a:sym typeface="Arial"/>
               </a:rPr>
-              <a:t>  Comparer les profils de toxicit&lt;c3&gt;&lt;a9&gt; entre doses</a:t>
+              <a:t>  Comparer les profils de toxicite entre doses</a:t>
             </a:r>
           </a:p>
           <a:p>
@@ -2966,7 +2966,7 @@
                 <a:ea typeface="Arial"/>
                 <a:sym typeface="Arial"/>
               </a:rPr>
-              <a:t>Option 3 &lt;e2&gt;&lt;80&gt;&lt;94&gt; Comparaison T-DXd vs T-DM1</a:t>
+              <a:t>Option 3 -- Comparaison T-DXd vs T-DM1</a:t>
             </a:r>
           </a:p>
           <a:p>
@@ -2994,7 +2994,7 @@
                 <a:ea typeface="Arial"/>
                 <a:sym typeface="Arial"/>
               </a:rPr>
-              <a:t>  T-DM1 (Kadcyla) : m&lt;c3&gt;&lt;aa&gt;me cible HER2, payload diff&lt;c3&gt;&lt;a9&gt;rent (DM1 vs DXd)</a:t>
+              <a:t>  T-DM1 (Kadcyla) : meme cible HER2, payload different (DM1 vs DXd)</a:t>
             </a:r>
           </a:p>
           <a:p>
@@ -3022,7 +3022,7 @@
                 <a:ea typeface="Arial"/>
                 <a:sym typeface="Arial"/>
               </a:rPr>
-              <a:t>  Comparer les profils de my&lt;c3&gt;&lt;a9&gt;losuppression avec le m&lt;c3&gt;&lt;aa&gt;me mod&lt;c3&gt;&lt;a8&gt;le</a:t>
+              <a:t>  Comparer les profils de myelosuppression avec le meme modele</a:t>
             </a:r>
           </a:p>
           <a:p>
@@ -3067,7 +3067,7 @@
                 <a:ea typeface="Arial"/>
                 <a:sym typeface="Arial"/>
               </a:rPr>
-              <a:t>Option 4 &lt;e2&gt;&lt;80&gt;&lt;94&gt; Adapter le mod&lt;c3&gt;&lt;a8&gt;le aux ADC (structure Ait-Oudhia 2017)</a:t>
+              <a:t>Option 4 -- Adapter le modele aux ADC (structure Ait-Oudhia 2017)</a:t>
             </a:r>
           </a:p>
           <a:p>
@@ -3095,7 +3095,7 @@
                 <a:ea typeface="Arial"/>
                 <a:sym typeface="Arial"/>
               </a:rPr>
-              <a:t>  Int&lt;c3&gt;&lt;a9&gt;grer un compartiment de relargage intratumoral</a:t>
+              <a:t>  Integrer un compartiment de relargage intratumoral</a:t>
             </a:r>
           </a:p>
         </p:txBody>
@@ -3196,7 +3196,7 @@
                 <a:ea typeface="Arial"/>
                 <a:sym typeface="Arial"/>
               </a:rPr>
-              <a:t>&lt;e2&gt;&lt;9c&gt;&lt;93&gt;  Mod&lt;c3&gt;&lt;a8&gt;le PK/PD T-DXd construit et calibr&lt;c3&gt;&lt;a9&gt; sur 2 esp&lt;c3&gt;&lt;a8&gt;ces</a:t>
+              <a:t>[OK]  Modele PK/PD T-DXd construit et calibre sur 2 especes</a:t>
             </a:r>
           </a:p>
           <a:p>
@@ -3241,7 +3241,7 @@
                 <a:ea typeface="Arial"/>
                 <a:sym typeface="Arial"/>
               </a:rPr>
-              <a:t>&lt;e2&gt;&lt;9c&gt;&lt;93&gt;  Rat : 3 seuils FDA reproduits (20 / 60 / 197 mg/kg)</a:t>
+              <a:t>[OK]  Rat : 3 seuils FDA reproduits (20 / 60 / 197 mg/kg)</a:t>
             </a:r>
           </a:p>
           <a:p>
@@ -3269,7 +3269,7 @@
                 <a:ea typeface="Arial"/>
                 <a:sym typeface="Arial"/>
               </a:rPr>
-              <a:t>&lt;e2&gt;&lt;9c&gt;&lt;93&gt;  Humain : G3-4 neutrop&lt;c3&gt;&lt;a9&gt;nie 18% (FDA 16-20%),  an&lt;c3&gt;&lt;a9&gt;mie 7% (FDA 9%)</a:t>
+              <a:t>[OK]  Humain : G3-4 neutropenie 18% (FDA 16-20%),  anemie 7% (FDA 9%)</a:t>
             </a:r>
           </a:p>
           <a:p>
@@ -3297,7 +3297,7 @@
                 <a:ea typeface="Arial"/>
                 <a:sym typeface="Arial"/>
               </a:rPr>
-              <a:t>&lt;e2&gt;&lt;9c&gt;&lt;93&gt;  PK valid&lt;c3&gt;&lt;a9&gt;e : ADC Cmax = 121 &lt;c2&gt;&lt;b5&gt;g/mL (FDA = 122)</a:t>
+              <a:t>[OK]  PK validee : ADC Cmax = 121 ug/mL (FDA = 122)</a:t>
             </a:r>
           </a:p>
           <a:p>
@@ -3342,7 +3342,7 @@
                 <a:ea typeface="Arial"/>
                 <a:sym typeface="Arial"/>
               </a:rPr>
-              <a:t>&lt;e2&gt;&lt;9a&gt;&lt;a0&gt;  Limitation : distribution des grades (G0 sous-estim&lt;c3&gt;&lt;a9&gt;)</a:t>
+              <a:t>[!]  Limitation : distribution des grades (G0 sous-estime)</a:t>
             </a:r>
           </a:p>
           <a:p>
@@ -3370,7 +3370,7 @@
                 <a:ea typeface="Arial"/>
                 <a:sym typeface="Arial"/>
               </a:rPr>
-              <a:t>     Cause : T&lt;c2&gt;&lt;bd&gt; ADC &gt; Q3W &lt;e2&gt;&lt;86&gt;&lt;92&gt; accumulation entre cycles</a:t>
+              <a:t>     Cause : T1/2 ADC &gt; Q3W -&gt; accumulation entre cycles</a:t>
             </a:r>
           </a:p>
           <a:p>
@@ -3398,7 +3398,7 @@
                 <a:ea typeface="Arial"/>
                 <a:sym typeface="Arial"/>
               </a:rPr>
-              <a:t>     Document&lt;c3&gt;&lt;a9&gt; : Ait-Oudhia et al. AAPS J 2017</a:t>
+              <a:t>     Reference : Ait-Oudhia et al. AAPS J 2017</a:t>
             </a:r>
           </a:p>
           <a:p>
@@ -3544,7 +3544,7 @@
                 <a:ea typeface="Arial"/>
                 <a:sym typeface="Arial"/>
               </a:rPr>
-              <a:t>1.  Mod&lt;c3&gt;&lt;a8&gt;le rat &lt;e2&gt;&lt;80&gt;&lt;94&gt; validation vs FDA BLA 761139</a:t>
+              <a:t>1.  Modele rat -- validation vs FDA BLA 761139</a:t>
             </a:r>
           </a:p>
           <a:p>
@@ -3617,7 +3617,7 @@
                 <a:ea typeface="Arial"/>
                 <a:sym typeface="Arial"/>
               </a:rPr>
-              <a:t>2.  Mod&lt;c3&gt;&lt;a8&gt;le humain &lt;e2&gt;&lt;80&gt;&lt;94&gt; validation vs DESTINY-Breast01</a:t>
+              <a:t>2.  Modele humain -- validation vs DESTINY-Breast01</a:t>
             </a:r>
           </a:p>
           <a:p>
@@ -3645,7 +3645,7 @@
                 <a:ea typeface="Arial"/>
                 <a:sym typeface="Arial"/>
               </a:rPr>
-              <a:t>     Grade 3-4 neutrop&lt;c3&gt;&lt;a9&gt;nie &amp; an&lt;c3&gt;&lt;a9&gt;mie  |  N = 200 patients simul&lt;c3&gt;&lt;a9&gt;s</a:t>
+              <a:t>     Grade 3-4 neutropenie &amp; anemie  |  N = 200 patients simules</a:t>
             </a:r>
           </a:p>
           <a:p>
@@ -3718,7 +3718,7 @@
                 <a:ea typeface="Arial"/>
                 <a:sym typeface="Arial"/>
               </a:rPr>
-              <a:t>     Accumulation ADC entre cycles &lt;e2&gt;&lt;86&gt;&lt;92&gt; surrepr&lt;c3&gt;&lt;a9&gt;sentation G2</a:t>
+              <a:t>     Accumulation ADC entre cycles -&gt; surrepresentation G2</a:t>
             </a:r>
           </a:p>
         </p:txBody>
@@ -3770,7 +3770,7 @@
           <a:p>
             <a:r>
               <a:rPr/>
-              <a:t>Structure du mod&lt;c3&gt;&lt;a8&gt;le PK/PD</a:t>
+              <a:t>Structure du modele PK/PD</a:t>
             </a:r>
           </a:p>
         </p:txBody>
@@ -3819,7 +3819,7 @@
                 <a:ea typeface="Arial"/>
                 <a:sym typeface="Arial"/>
               </a:rPr>
-              <a:t>PK &lt;e2&gt;&lt;80&gt;&lt;94&gt; T-DXd (ADC 2 compartiments, Yin 2020)</a:t>
+              <a:t>PK -- T-DXd (ADC 2 compartiments, Yin 2020)</a:t>
             </a:r>
           </a:p>
           <a:p>
@@ -3847,7 +3847,7 @@
                 <a:ea typeface="Arial"/>
                 <a:sym typeface="Arial"/>
               </a:rPr>
-              <a:t>  ADC s&lt;c3&gt;&lt;a9&gt;rum  &lt;e2&gt;&lt;86&gt;&lt;92&gt;  DXd plasma  &lt;e2&gt;&lt;86&gt;&lt;92&gt;  DXd intracellulaire  &lt;e2&gt;&lt;86&gt;&lt;92&gt;  Dommages ADN (Damage)</a:t>
+              <a:t>  ADC serum -&gt; DXd plasma -&gt; DXd intracellulaire -&gt; Dommages ADN (Damage)</a:t>
             </a:r>
           </a:p>
           <a:p>
@@ -3892,7 +3892,7 @@
                 <a:ea typeface="Arial"/>
                 <a:sym typeface="Arial"/>
               </a:rPr>
-              <a:t>PD &lt;e2&gt;&lt;80&gt;&lt;94&gt; H&lt;c3&gt;&lt;a9&gt;matopo&lt;c3&gt;&lt;af&gt;&lt;c3&gt;&lt;a8&gt;se (Fornari 2019)</a:t>
+              <a:t>PD -- Hematopoiese (Fornari 2019)</a:t>
             </a:r>
           </a:p>
           <a:p>
@@ -3920,7 +3920,7 @@
                 <a:ea typeface="Arial"/>
                 <a:sym typeface="Arial"/>
               </a:rPr>
-              <a:t>  MPP  &lt;e2&gt;&lt;86&gt;&lt;92&gt;  CMP  &lt;e2&gt;&lt;86&gt;&lt;92&gt;  Neutrophiles / Monocytes</a:t>
+              <a:t>  MPP -&gt; CMP -&gt; Neutrophiles / Monocytes</a:t>
             </a:r>
           </a:p>
           <a:p>
@@ -3948,7 +3948,7 @@
                 <a:ea typeface="Arial"/>
                 <a:sym typeface="Arial"/>
               </a:rPr>
-              <a:t>  MPP  &lt;e2&gt;&lt;86&gt;&lt;92&gt;  MEP  &lt;e2&gt;&lt;86&gt;&lt;92&gt;  &lt;c3&gt;&lt;89&gt;rythroblastes / Plaquettes</a:t>
+              <a:t>  MPP -&gt; MEP -&gt; Erythroblastes / Plaquettes</a:t>
             </a:r>
           </a:p>
           <a:p>
@@ -3993,7 +3993,7 @@
                 <a:ea typeface="Arial"/>
                 <a:sym typeface="Arial"/>
               </a:rPr>
-              <a:t>Lien PK&lt;e2&gt;&lt;86&gt;&lt;92&gt;PD : Damage inhibe la prolif&lt;c3&gt;&lt;a9&gt;ration des prog&lt;c3&gt;&lt;a9&gt;niteurs</a:t>
+              <a:t>Lien PK-&gt;PD : Damage inhibe la proliferation des progeniteurs</a:t>
             </a:r>
           </a:p>
           <a:p>
@@ -4021,7 +4021,7 @@
                 <a:ea typeface="Arial"/>
                 <a:sym typeface="Arial"/>
               </a:rPr>
-              <a:t>  dCMP/dt &lt;e2&gt;&lt;88&gt;&lt;9d&gt; (1 &lt;e2&gt;&lt;88&gt;&lt;92&gt; Slope_CMP &lt;c3&gt;&lt;97&gt; Damage) &lt;c3&gt;&lt;97&gt; CMP</a:t>
+              <a:t>  dCMP/dt ~ (1 - Slope_CMP x Damage) x CMP</a:t>
             </a:r>
           </a:p>
           <a:p>
@@ -4066,7 +4066,7 @@
                 <a:ea typeface="Arial"/>
                 <a:sym typeface="Arial"/>
               </a:rPr>
-              <a:t>Driver toxicit&lt;c3&gt;&lt;a9&gt; : C_ADC1 [&lt;c2&gt;&lt;b5&gt;g/mL]  (assay PFB-10 sur HPC, IC50 = 27.7 &lt;c2&gt;&lt;b5&gt;g/mL)</a:t>
+              <a:t>Driver toxicite : C_ADC1 [ug/mL]  (assay PFB-10 sur HPC, IC50 = 27.7 ug/mL)</a:t>
             </a:r>
           </a:p>
         </p:txBody>
@@ -4118,7 +4118,7 @@
           <a:p>
             <a:r>
               <a:rPr/>
-              <a:t>Rat &lt;e2&gt;&lt;80&gt;&lt;94&gt; Validation vs seuils FDA BLA 761139 (Table 6)</a:t>
+              <a:t>Rat -- Validation vs seuils FDA BLA 761139 (Table 6)</a:t>
             </a:r>
           </a:p>
         </p:txBody>
@@ -4196,7 +4196,7 @@
           <a:p>
             <a:r>
               <a:rPr/>
-              <a:t>Rat &lt;e2&gt;&lt;80&gt;&lt;94&gt; Profils temporels sur 3 cycles (63 jours)</a:t>
+              <a:t>Rat -- Profils temporels sur 3 cycles (63 jours)</a:t>
             </a:r>
           </a:p>
         </p:txBody>
@@ -4274,7 +4274,7 @@
           <a:p>
             <a:r>
               <a:rPr/>
-              <a:t>Rat &lt;e2&gt;&lt;80&gt;&lt;94&gt; R&lt;c3&gt;&lt;a9&gt;sultats cl&lt;c3&gt;&lt;a9&gt;s</a:t>
+              <a:t>Rat -- Resultats cles</a:t>
             </a:r>
           </a:p>
         </p:txBody>
@@ -4396,7 +4396,7 @@
                 <a:ea typeface="Arial"/>
                 <a:sym typeface="Arial"/>
               </a:rPr>
-              <a:t>20 mg/kg    &lt;e2&gt;&lt;88&gt;&lt;92&gt;14.0%        &lt;e2&gt;&lt;88&gt;&lt;92&gt;9.8%          &lt;e2&gt;&lt;88&gt;&lt;92&gt;4.3%     &lt;e2&gt;&lt;86&gt;&lt;93&gt; Ret &lt;e2&gt;&lt;89&gt;&lt;a5&gt; 20 mg/kg  &lt;e2&gt;&lt;9c&gt;&lt;93&gt;</a:t>
+              <a:t>20 mg/kg    -14.0%        -9.8%          -4.3%     Ret chute &gt;= 20 mg/kg  [OK]</a:t>
             </a:r>
           </a:p>
           <a:p>
@@ -4424,7 +4424,7 @@
                 <a:ea typeface="Arial"/>
                 <a:sym typeface="Arial"/>
               </a:rPr>
-              <a:t>60 mg/kg    &lt;e2&gt;&lt;88&gt;&lt;92&gt;32.5%        &lt;e2&gt;&lt;88&gt;&lt;92&gt;23.7%         &lt;e2&gt;&lt;88&gt;&lt;92&gt;10.9%    &lt;e2&gt;&lt;86&gt;&lt;93&gt; MEP &lt;e2&gt;&lt;89&gt;&lt;a5&gt; 60 mg/kg  &lt;e2&gt;&lt;9c&gt;&lt;93&gt;</a:t>
+              <a:t>60 mg/kg    -32.5%        -23.7%         -10.9%    MEP chute &gt;= 60 mg/kg  [OK]</a:t>
             </a:r>
           </a:p>
           <a:p>
@@ -4452,7 +4452,7 @@
                 <a:ea typeface="Arial"/>
                 <a:sym typeface="Arial"/>
               </a:rPr>
-              <a:t>197 mg/kg   &lt;e2&gt;&lt;88&gt;&lt;92&gt;59.6%        &lt;e2&gt;&lt;88&gt;&lt;92&gt;46.9%         &lt;e2&gt;&lt;88&gt;&lt;92&gt;24.3%    &lt;e2&gt;&lt;86&gt;&lt;93&gt; Neut &lt;e2&gt;&lt;89&gt;&lt;a5&gt; 197 mg/kg &lt;e2&gt;&lt;9c&gt;&lt;93&gt;</a:t>
+              <a:t>197 mg/kg   -59.6%        -46.9%         -24.3%    Neut chute &gt;= 197 mg/kg  [OK]</a:t>
             </a:r>
           </a:p>
           <a:p>
@@ -4497,7 +4497,7 @@
                 <a:ea typeface="Arial"/>
                 <a:sym typeface="Arial"/>
               </a:rPr>
-              <a:t>Les 3 seuils de dose FDA sont reproduits par le mod&lt;c3&gt;&lt;a8&gt;le.</a:t>
+              <a:t>Les 3 seuils de dose FDA sont reproduits par le modele.</a:t>
             </a:r>
           </a:p>
         </p:txBody>
@@ -4549,7 +4549,7 @@
           <a:p>
             <a:r>
               <a:rPr/>
-              <a:t>Humain &lt;e2&gt;&lt;80&gt;&lt;94&gt; Grades neutrop&lt;c3&gt;&lt;a9&gt;nie : mod&lt;c3&gt;&lt;a8&gt;le vs DESTINY-Breast01</a:t>
+              <a:t>Humain -- Grades neutropenie : modele vs DESTINY-Breast01</a:t>
             </a:r>
           </a:p>
         </p:txBody>
@@ -4627,7 +4627,7 @@
           <a:p>
             <a:r>
               <a:rPr/>
-              <a:t>Humain &lt;e2&gt;&lt;80&gt;&lt;94&gt; Grades an&lt;c3&gt;&lt;a9&gt;mie : mod&lt;c3&gt;&lt;a8&gt;le vs DESTINY-Breast01</a:t>
+              <a:t>Humain -- Grades anemie : modele vs DESTINY-Breast01</a:t>
             </a:r>
           </a:p>
         </p:txBody>
@@ -4705,7 +4705,7 @@
           <a:p>
             <a:r>
               <a:rPr/>
-              <a:t>Humain &lt;e2&gt;&lt;80&gt;&lt;94&gt; R&lt;c3&gt;&lt;a9&gt;sultats cl&lt;c3&gt;&lt;a9&gt;s (N = 200 patients)</a:t>
+              <a:t>Humain -- Resultats cles (N = 200 patients)</a:t>
             </a:r>
           </a:p>
         </p:txBody>
@@ -4754,7 +4754,7 @@
                 <a:ea typeface="Arial"/>
                 <a:sym typeface="Arial"/>
               </a:rPr>
-              <a:t>PK &lt;e2&gt;&lt;80&gt;&lt;94&gt; Validation vs FDA BLA 761139 :</a:t>
+              <a:t>PK -- Validation vs FDA BLA 761139 :</a:t>
             </a:r>
           </a:p>
           <a:p>
@@ -4782,7 +4782,7 @@
                 <a:ea typeface="Arial"/>
                 <a:sym typeface="Arial"/>
               </a:rPr>
-              <a:t>  ADC Cmax = 121 &lt;c2&gt;&lt;b5&gt;g/mL  (FDA = 122)  &lt;e2&gt;&lt;9c&gt;&lt;93&gt;</a:t>
+              <a:t>  ADC Cmax = 121 ug/mL  (FDA = 122)  [OK]</a:t>
             </a:r>
           </a:p>
           <a:p>
@@ -4810,7 +4810,7 @@
                 <a:ea typeface="Arial"/>
                 <a:sym typeface="Arial"/>
               </a:rPr>
-              <a:t>  DXd Cmax = 3.8 ng/mL  (FDA = 4.4)  &lt;e2&gt;&lt;9c&gt;&lt;93&gt;</a:t>
+              <a:t>  DXd Cmax = 3.8 ng/mL  (FDA = 4.4)  [OK]</a:t>
             </a:r>
           </a:p>
           <a:p>
@@ -4855,7 +4855,7 @@
                 <a:ea typeface="Arial"/>
                 <a:sym typeface="Arial"/>
               </a:rPr>
-              <a:t>PD &lt;e2&gt;&lt;80&gt;&lt;94&gt; Toxicit&lt;c3&gt;&lt;a9&gt; h&lt;c3&gt;&lt;a9&gt;matologique (Slope_CMP = 12, calibr&lt;c3&gt;&lt;a9&gt;) :</a:t>
+              <a:t>PD -- Toxicite hematologique (Slope_CMP = 12, calibre) :</a:t>
             </a:r>
           </a:p>
           <a:p>
@@ -4883,7 +4883,7 @@
                 <a:ea typeface="Arial"/>
                 <a:sym typeface="Arial"/>
               </a:rPr>
-              <a:t>  Neutrop&lt;c3&gt;&lt;a9&gt;nie G3-4 : 18%   (FDA : 16-20%)  &lt;e2&gt;&lt;9c&gt;&lt;93&gt;</a:t>
+              <a:t>  Neutropenie G3-4 : 18%   (FDA : 16-20%)  [OK]</a:t>
             </a:r>
           </a:p>
           <a:p>
@@ -4911,7 +4911,7 @@
                 <a:ea typeface="Arial"/>
                 <a:sym typeface="Arial"/>
               </a:rPr>
-              <a:t>  An&lt;c3&gt;&lt;a9&gt;mie G3-4      :  7%   (FDA :  ~9%)    &lt;e2&gt;&lt;9c&gt;&lt;93&gt;</a:t>
+              <a:t>  Anemie G3-4      :  7%   (FDA :  ~9%)    [OK]</a:t>
             </a:r>
           </a:p>
           <a:p>
@@ -4939,7 +4939,7 @@
                 <a:ea typeface="Arial"/>
                 <a:sym typeface="Arial"/>
               </a:rPr>
-              <a:t>  Nadir Neut m&lt;c3&gt;&lt;a9&gt;dian : 1.22 &lt;c3&gt;&lt;97&gt; 10&lt;e2&gt;&lt;81&gt;&lt;b9&gt;/L</a:t>
+              <a:t>  Nadir Neut median : 1.22 x 10^9/L</a:t>
             </a:r>
           </a:p>
           <a:p>
@@ -4984,7 +4984,7 @@
                 <a:ea typeface="Arial"/>
                 <a:sym typeface="Arial"/>
               </a:rPr>
-              <a:t>&lt;e2&gt;&lt;9a&gt;&lt;a0&gt;  Tout grade : 100% (mod&lt;c3&gt;&lt;a8&gt;le) vs 29% (FDA)  &lt;e2&gt;&lt;86&gt;&lt;92&gt; limitation</a:t>
+              <a:t>[!]  Tout grade : 100% (modele) vs 29% (FDA)  -&gt; limitation</a:t>
             </a:r>
           </a:p>
         </p:txBody>

</xml_diff>